<commit_message>
docs(coursework): reframe positioning as multi-tenant SaaS with tariff plans
- relevance/comparison/concept slides: drop misleading 'open-source self-hosted alternative' framing; explicitly position TaskHub as a B2B-SaaS prototype with tariff plans (FREE/BASIC/PRO/ENTERPRISE) deployable on-premise
- architecture: add Billing module (10 modules total), mention PlanGuard / PlanLimitsService / YooKassa
- comparison table: switch criterion 'Open code' to 'Tariffs' to match actual product positioning
- defense speech: matching narrative + new Q&A entry on subscription module rationale
</commit_message>
<xml_diff>
--- a/docs/coursework/Презентация_TaskHub.pptx
+++ b/docs/coursework/Презентация_TaskHub.pptx
@@ -4224,7 +4224,7 @@
               </a:spcAft>
             </a:pPr>
             <a:r>
-              <a:rPr sz="1700">
+              <a:rPr sz="1500">
                 <a:solidFill>
                   <a:srgbClr val="1A1F2B"/>
                 </a:solidFill>
@@ -4240,13 +4240,13 @@
               </a:spcAft>
             </a:pPr>
             <a:r>
-              <a:rPr sz="1700">
+              <a:rPr sz="1500">
                 <a:solidFill>
                   <a:srgbClr val="1A1F2B"/>
                 </a:solidFill>
                 <a:latin typeface="Calibri"/>
               </a:rPr>
-              <a:t>•  Backend: NestJS + TypeORM, 9 модулей (Auth, Tenants, Users, Projects, Issues, Search, Notifications, Mail, Health).</a:t>
+              <a:t>•  Backend: NestJS + TypeORM, 10 модулей (Auth, Tenants, Users, Projects, Issues, Search, Notifications, Health, Billing, Redis).</a:t>
             </a:r>
           </a:p>
           <a:p>
@@ -4256,7 +4256,7 @@
               </a:spcAft>
             </a:pPr>
             <a:r>
-              <a:rPr sz="1700">
+              <a:rPr sz="1500">
                 <a:solidFill>
                   <a:srgbClr val="1A1F2B"/>
                 </a:solidFill>
@@ -4272,13 +4272,13 @@
               </a:spcAft>
             </a:pPr>
             <a:r>
-              <a:rPr sz="1700">
+              <a:rPr sz="1500">
                 <a:solidFill>
                   <a:srgbClr val="1A1F2B"/>
                 </a:solidFill>
                 <a:latin typeface="Calibri"/>
               </a:rPr>
-              <a:t>•  Реал-тайм: WebSocket (Socket.IO) + EventEmitter для развязки слоёв.</a:t>
+              <a:t>•  Биллинг: YooKassa-интеграция + PlanGuard, ограничения по тарифам (projects/users/issues).</a:t>
             </a:r>
           </a:p>
           <a:p>
@@ -4288,7 +4288,23 @@
               </a:spcAft>
             </a:pPr>
             <a:r>
-              <a:rPr sz="1700">
+              <a:rPr sz="1500">
+                <a:solidFill>
+                  <a:srgbClr val="1A1F2B"/>
+                </a:solidFill>
+                <a:latin typeface="Calibri"/>
+              </a:rPr>
+              <a:t>•  Реал-тайм: WebSocket (Socket.IO) + EventEmitter для развязки слоёв.</a:t>
+            </a:r>
+          </a:p>
+          <a:p>
+            <a:pPr algn="l">
+              <a:spcAft>
+                <a:spcPts val="600"/>
+              </a:spcAft>
+            </a:pPr>
+            <a:r>
+              <a:rPr sz="1500">
                 <a:solidFill>
                   <a:srgbClr val="1A1F2B"/>
                 </a:solidFill>
@@ -6313,7 +6329,7 @@
                 </a:solidFill>
                 <a:latin typeface="Calibri"/>
               </a:rPr>
-              <a:t>•  Облачные сервисы (Jira, Asana, Linear) — vendor lock-in, рост стоимости лицензий, требования к локализации данных.</a:t>
+              <a:t>•  Зарубежные SaaS (Jira, Asana, Linear) — vendor lock-in, рост стоимости лицензий, требования к локализации данных и платежам.</a:t>
             </a:r>
           </a:p>
           <a:p>
@@ -6329,7 +6345,7 @@
                 </a:solidFill>
                 <a:latin typeface="Calibri"/>
               </a:rPr>
-              <a:t>•  Тренд на self-hosted решения с поддержкой multi-tenant изоляции.</a:t>
+              <a:t>•  B2B-SaaS как продуктовая модель: multi-tenant изоляция + тарифные планы + интеграция с локальной платёжной системой.</a:t>
             </a:r>
           </a:p>
           <a:p>
@@ -6345,7 +6361,7 @@
                 </a:solidFill>
                 <a:latin typeface="Calibri"/>
               </a:rPr>
-              <a:t>•  Современный стек (NestJS, React, PostgreSQL) делает разработку прототипа реалистичной задачей курсовой работы.</a:t>
+              <a:t>•  Современный стек (NestJS, React, PostgreSQL) делает разработку такого прототипа реалистичной задачей курсовой работы.</a:t>
             </a:r>
           </a:p>
         </p:txBody>
@@ -6479,7 +6495,7 @@
                 </a:solidFill>
                 <a:latin typeface="Calibri"/>
               </a:rPr>
-              <a:t>multi-tenant</a:t>
+              <a:t>4 тарифа</a:t>
             </a:r>
           </a:p>
           <a:p>
@@ -6490,7 +6506,7 @@
                 </a:solidFill>
                 <a:latin typeface="Calibri"/>
               </a:rPr>
-              <a:t>ключевое требование к B2B-SaaS</a:t>
+              <a:t>FREE · BASIC · PRO · ENTERPRISE</a:t>
             </a:r>
           </a:p>
           <a:p>
@@ -6517,7 +6533,7 @@
                 </a:solidFill>
                 <a:latin typeface="Calibri"/>
               </a:rPr>
-              <a:t>механизм изоляции в PostgreSQL</a:t>
+              <a:t>механизм изоляции арендаторов в PostgreSQL</a:t>
             </a:r>
           </a:p>
         </p:txBody>
@@ -7790,7 +7806,7 @@
                 </a:solidFill>
                 <a:latin typeface="Calibri"/>
               </a:rPr>
-              <a:t>SaaS / on-premise / self-hosted</a:t>
+              <a:t>SaaS · on-premise · self-hosted</a:t>
             </a:r>
           </a:p>
           <a:p>
@@ -7856,7 +7872,7 @@
                 </a:solidFill>
                 <a:latin typeface="Calibri"/>
               </a:rPr>
-              <a:t>По интеграции:  </a:t>
+              <a:t>Монетизация:  </a:t>
             </a:r>
             <a:r>
               <a:rPr sz="1400">
@@ -7865,7 +7881,7 @@
                 </a:solidFill>
                 <a:latin typeface="Calibri"/>
               </a:rPr>
-              <a:t>Standalone · DevOps-стек</a:t>
+              <a:t>Free · Freemium · Subscription</a:t>
             </a:r>
           </a:p>
         </p:txBody>
@@ -8220,7 +8236,7 @@
                           </a:solidFill>
                           <a:latin typeface="Calibri"/>
                         </a:rPr>
-                        <a:t>Self-hosted</a:t>
+                        <a:t>Поставка</a:t>
                       </a:r>
                     </a:p>
                   </a:txBody>
@@ -8266,7 +8282,7 @@
                           </a:solidFill>
                           <a:latin typeface="Calibri"/>
                         </a:rPr>
-                        <a:t>Открытый код</a:t>
+                        <a:t>Тарифы</a:t>
                       </a:r>
                     </a:p>
                   </a:txBody>
@@ -8337,7 +8353,7 @@
                           </a:solidFill>
                           <a:latin typeface="Calibri"/>
                         </a:rPr>
-                        <a:t>DC (платно)</a:t>
+                        <a:t>Cloud + DC</a:t>
                       </a:r>
                     </a:p>
                   </a:txBody>
@@ -8383,7 +8399,7 @@
                           </a:solidFill>
                           <a:latin typeface="Calibri"/>
                         </a:rPr>
-                        <a:t>Нет</a:t>
+                        <a:t>Per-user</a:t>
                       </a:r>
                     </a:p>
                   </a:txBody>
@@ -8500,7 +8516,7 @@
                           </a:solidFill>
                           <a:latin typeface="Calibri"/>
                         </a:rPr>
-                        <a:t>Нет</a:t>
+                        <a:t>С GitHub</a:t>
                       </a:r>
                     </a:p>
                   </a:txBody>
@@ -8617,7 +8633,7 @@
                           </a:solidFill>
                           <a:latin typeface="Calibri"/>
                         </a:rPr>
-                        <a:t>Нет</a:t>
+                        <a:t>Free / Premium</a:t>
                       </a:r>
                     </a:p>
                   </a:txBody>
@@ -8688,7 +8704,7 @@
                           </a:solidFill>
                           <a:latin typeface="Calibri"/>
                         </a:rPr>
-                        <a:t>Да</a:t>
+                        <a:t>Cloud + on-prem</a:t>
                       </a:r>
                     </a:p>
                   </a:txBody>
@@ -8734,7 +8750,7 @@
                           </a:solidFill>
                           <a:latin typeface="Calibri"/>
                         </a:rPr>
-                        <a:t>Нет</a:t>
+                        <a:t>Per-user</a:t>
                       </a:r>
                     </a:p>
                   </a:txBody>
@@ -8805,7 +8821,7 @@
                           </a:solidFill>
                           <a:latin typeface="Calibri"/>
                         </a:rPr>
-                        <a:t>Да</a:t>
+                        <a:t>On-prem</a:t>
                       </a:r>
                     </a:p>
                   </a:txBody>
@@ -8851,7 +8867,7 @@
                           </a:solidFill>
                           <a:latin typeface="Calibri"/>
                         </a:rPr>
-                        <a:t>Да</a:t>
+                        <a:t>Community / Ent.</a:t>
                       </a:r>
                     </a:p>
                   </a:txBody>
@@ -8922,7 +8938,7 @@
                           </a:solidFill>
                           <a:latin typeface="Calibri"/>
                         </a:rPr>
-                        <a:t>Да</a:t>
+                        <a:t>On-prem (Docker)</a:t>
                       </a:r>
                     </a:p>
                   </a:txBody>
@@ -8968,7 +8984,7 @@
                           </a:solidFill>
                           <a:latin typeface="Calibri"/>
                         </a:rPr>
-                        <a:t>Да</a:t>
+                        <a:t>4 плана + YooKassa</a:t>
                       </a:r>
                     </a:p>
                   </a:txBody>

</xml_diff>